<commit_message>
docs(perf): rebuild 性能分析 page (混合 A+B 风格)
Removed v3 vs v4 comparison (per user request).
Restructured to 5 sections matching mixed user-experience + tech-depth:

1. 🎯 用户感知性能 (4 big metric cards)
   - <1s 飞书 ack / ~12s 告警通知 / 95-97% MTTR改进 / <0.1% 错误率

2. ⏱️ 告警闭环关键路径耗时分解 (table with 6 stages)
   - DOA Investigation 占 99% 耗时 (highlighted)
   - 配 '换深度换时间' 解读

3. 🛠️ 5 个 MCP 工具耗时 + 📊 系统扩展性 (并排)
   - 工具耗时表 (5 工具)
   - 扩展能力表 (Lambda/APIGW/DOA/DDB/调用量,扩展余量 25x)

4. ⚡ Lambda 自身性能
   - 冷启动/热启动/平均执行/内存峰值/错误率

5. ⚡ MTTR 改进趋势 (ECharts折线图保留)

Files updated:
- assets/...v7.pptx (slide 17 性能分析 重写)
- docs/v6-overview.html (1️⃣1️⃣ 性能分析 重写)
</commit_message>
<xml_diff>
--- a/assets/AB：自然语言驱动的 AI 运维平台-v7.pptx
+++ b/assets/AB：自然语言驱动的 AI 运维平台-v7.pptx
@@ -8489,23 +8489,91 @@
       <p:grpSpPr/>
       <p:sp>
         <p:nvSpPr>
-          <p:cNvPr id="2" name="Rectangle 1"/>
+          <p:cNvPr id="4" name="TextBox 3"/>
+          <p:cNvSpPr txBox="1"/>
+          <p:nvPr/>
+        </p:nvSpPr>
+        <p:spPr>
+          <a:xfrm>
+            <a:off x="457200" y="164592"/>
+            <a:ext cx="11247120" cy="502920"/>
+          </a:xfrm>
+          <a:prstGeom prst="rect">
+            <a:avLst/>
+          </a:prstGeom>
+          <a:noFill/>
+        </p:spPr>
+        <p:txBody>
+          <a:bodyPr wrap="none">
+            <a:spAutoFit/>
+          </a:bodyPr>
+          <a:lstStyle/>
+          <a:p>
+            <a:r>
+              <a:rPr sz="2600" b="1">
+                <a:solidFill>
+                  <a:srgbClr val="FFFFFF"/>
+                </a:solidFill>
+              </a:rPr>
+              <a:t>16. 性能分析</a:t>
+            </a:r>
+          </a:p>
+        </p:txBody>
+      </p:sp>
+      <p:sp>
+        <p:nvSpPr>
+          <p:cNvPr id="5" name="TextBox 4"/>
+          <p:cNvSpPr txBox="1"/>
+          <p:nvPr/>
+        </p:nvSpPr>
+        <p:spPr>
+          <a:xfrm>
+            <a:off x="457200" y="960120"/>
+            <a:ext cx="11247120" cy="365760"/>
+          </a:xfrm>
+          <a:prstGeom prst="rect">
+            <a:avLst/>
+          </a:prstGeom>
+          <a:noFill/>
+        </p:spPr>
+        <p:txBody>
+          <a:bodyPr wrap="square">
+            <a:spAutoFit/>
+          </a:bodyPr>
+          <a:lstStyle/>
+          <a:p>
+            <a:r>
+              <a:rPr sz="1400" b="1">
+                <a:solidFill>
+                  <a:srgbClr val="232F3E"/>
+                </a:solidFill>
+              </a:rPr>
+              <a:t>🎯 用户感知性能</a:t>
+            </a:r>
+          </a:p>
+        </p:txBody>
+      </p:sp>
+      <p:sp>
+        <p:nvSpPr>
+          <p:cNvPr id="6" name="Rounded Rectangle 5"/>
           <p:cNvSpPr/>
           <p:nvPr/>
         </p:nvSpPr>
         <p:spPr>
           <a:xfrm>
-            <a:off x="0" y="0"/>
-            <a:ext cx="12191695" cy="777240"/>
-          </a:xfrm>
-          <a:prstGeom prst="rect">
+            <a:off x="457200" y="1417320"/>
+            <a:ext cx="2697480" cy="1188720"/>
+          </a:xfrm>
+          <a:prstGeom prst="roundRect">
             <a:avLst/>
           </a:prstGeom>
           <a:solidFill>
-            <a:srgbClr val="232F3E"/>
+            <a:srgbClr val="FFFFFF"/>
           </a:solidFill>
-          <a:ln>
-            <a:noFill/>
+          <a:ln w="6350">
+            <a:solidFill>
+              <a:srgbClr val="E5E7EB"/>
+            </a:solidFill>
           </a:ln>
         </p:spPr>
         <p:style>
@@ -8532,23 +8600,93 @@
       </p:sp>
       <p:sp>
         <p:nvSpPr>
-          <p:cNvPr id="3" name="Rectangle 2"/>
+          <p:cNvPr id="7" name="TextBox 6"/>
+          <p:cNvSpPr txBox="1"/>
+          <p:nvPr/>
+        </p:nvSpPr>
+        <p:spPr>
+          <a:xfrm>
+            <a:off x="457200" y="1600200"/>
+            <a:ext cx="2697480" cy="594360"/>
+          </a:xfrm>
+          <a:prstGeom prst="rect">
+            <a:avLst/>
+          </a:prstGeom>
+          <a:noFill/>
+        </p:spPr>
+        <p:txBody>
+          <a:bodyPr wrap="none">
+            <a:spAutoFit/>
+          </a:bodyPr>
+          <a:lstStyle/>
+          <a:p>
+            <a:pPr algn="ctr"/>
+            <a:r>
+              <a:rPr sz="2800" b="1">
+                <a:solidFill>
+                  <a:srgbClr val="FF9900"/>
+                </a:solidFill>
+              </a:rPr>
+              <a:t>&lt; 1 秒</a:t>
+            </a:r>
+          </a:p>
+        </p:txBody>
+      </p:sp>
+      <p:sp>
+        <p:nvSpPr>
+          <p:cNvPr id="8" name="TextBox 7"/>
+          <p:cNvSpPr txBox="1"/>
+          <p:nvPr/>
+        </p:nvSpPr>
+        <p:spPr>
+          <a:xfrm>
+            <a:off x="457200" y="2071116"/>
+            <a:ext cx="2697480" cy="475488"/>
+          </a:xfrm>
+          <a:prstGeom prst="rect">
+            <a:avLst/>
+          </a:prstGeom>
+          <a:noFill/>
+        </p:spPr>
+        <p:txBody>
+          <a:bodyPr wrap="none">
+            <a:spAutoFit/>
+          </a:bodyPr>
+          <a:lstStyle/>
+          <a:p>
+            <a:pPr algn="ctr"/>
+            <a:r>
+              <a:rPr sz="1100">
+                <a:solidFill>
+                  <a:srgbClr val="1F2937"/>
+                </a:solidFill>
+              </a:rPr>
+              <a:t>飞书 @机器人 ack</a:t>
+            </a:r>
+          </a:p>
+        </p:txBody>
+      </p:sp>
+      <p:sp>
+        <p:nvSpPr>
+          <p:cNvPr id="9" name="Rounded Rectangle 8"/>
           <p:cNvSpPr/>
           <p:nvPr/>
         </p:nvSpPr>
         <p:spPr>
           <a:xfrm>
-            <a:off x="0" y="777240"/>
-            <a:ext cx="365760" cy="73152"/>
-          </a:xfrm>
-          <a:prstGeom prst="rect">
+            <a:off x="3337560" y="1417320"/>
+            <a:ext cx="2697480" cy="1188720"/>
+          </a:xfrm>
+          <a:prstGeom prst="roundRect">
             <a:avLst/>
           </a:prstGeom>
           <a:solidFill>
-            <a:srgbClr val="FF9900"/>
+            <a:srgbClr val="FFFFFF"/>
           </a:solidFill>
-          <a:ln>
-            <a:noFill/>
+          <a:ln w="6350">
+            <a:solidFill>
+              <a:srgbClr val="E5E7EB"/>
+            </a:solidFill>
           </a:ln>
         </p:spPr>
         <p:style>
@@ -8575,14 +8713,14 @@
       </p:sp>
       <p:sp>
         <p:nvSpPr>
-          <p:cNvPr id="4" name="TextBox 3"/>
+          <p:cNvPr id="10" name="TextBox 9"/>
           <p:cNvSpPr txBox="1"/>
           <p:nvPr/>
         </p:nvSpPr>
         <p:spPr>
           <a:xfrm>
-            <a:off x="457200" y="164592"/>
-            <a:ext cx="11247120" cy="502920"/>
+            <a:off x="3337560" y="1600200"/>
+            <a:ext cx="2697480" cy="594360"/>
           </a:xfrm>
           <a:prstGeom prst="rect">
             <a:avLst/>
@@ -8595,26 +8733,287 @@
           </a:bodyPr>
           <a:lstStyle/>
           <a:p>
-            <a:r>
-              <a:rPr sz="2600" b="1">
-                <a:solidFill>
-                  <a:srgbClr val="FFFFFF"/>
-                </a:solidFill>
-              </a:rPr>
-              <a:t>16. 性能分析</a:t>
-            </a:r>
-          </a:p>
-        </p:txBody>
-      </p:sp>
-      <p:sp>
-        <p:nvSpPr>
-          <p:cNvPr id="5" name="TextBox 4"/>
+            <a:pPr algn="ctr"/>
+            <a:r>
+              <a:rPr sz="2800" b="1">
+                <a:solidFill>
+                  <a:srgbClr val="146EB4"/>
+                </a:solidFill>
+              </a:rPr>
+              <a:t>~12 秒</a:t>
+            </a:r>
+          </a:p>
+        </p:txBody>
+      </p:sp>
+      <p:sp>
+        <p:nvSpPr>
+          <p:cNvPr id="11" name="TextBox 10"/>
           <p:cNvSpPr txBox="1"/>
           <p:nvPr/>
         </p:nvSpPr>
         <p:spPr>
           <a:xfrm>
-            <a:off x="457200" y="960120"/>
+            <a:off x="3337560" y="2071116"/>
+            <a:ext cx="2697480" cy="475488"/>
+          </a:xfrm>
+          <a:prstGeom prst="rect">
+            <a:avLst/>
+          </a:prstGeom>
+          <a:noFill/>
+        </p:spPr>
+        <p:txBody>
+          <a:bodyPr wrap="none">
+            <a:spAutoFit/>
+          </a:bodyPr>
+          <a:lstStyle/>
+          <a:p>
+            <a:pPr algn="ctr"/>
+            <a:r>
+              <a:rPr sz="1100">
+                <a:solidFill>
+                  <a:srgbClr val="1F2937"/>
+                </a:solidFill>
+              </a:rPr>
+              <a:t>告警 → SRE 通知</a:t>
+            </a:r>
+          </a:p>
+        </p:txBody>
+      </p:sp>
+      <p:sp>
+        <p:nvSpPr>
+          <p:cNvPr id="12" name="Rounded Rectangle 11"/>
+          <p:cNvSpPr/>
+          <p:nvPr/>
+        </p:nvSpPr>
+        <p:spPr>
+          <a:xfrm>
+            <a:off x="6217920" y="1417320"/>
+            <a:ext cx="2697480" cy="1188720"/>
+          </a:xfrm>
+          <a:prstGeom prst="roundRect">
+            <a:avLst/>
+          </a:prstGeom>
+          <a:solidFill>
+            <a:srgbClr val="FFFFFF"/>
+          </a:solidFill>
+          <a:ln w="6350">
+            <a:solidFill>
+              <a:srgbClr val="E5E7EB"/>
+            </a:solidFill>
+          </a:ln>
+        </p:spPr>
+        <p:style>
+          <a:lnRef idx="1">
+            <a:schemeClr val="accent1"/>
+          </a:lnRef>
+          <a:fillRef idx="3">
+            <a:schemeClr val="accent1"/>
+          </a:fillRef>
+          <a:effectRef idx="2">
+            <a:schemeClr val="accent1"/>
+          </a:effectRef>
+          <a:fontRef idx="minor">
+            <a:schemeClr val="lt1"/>
+          </a:fontRef>
+        </p:style>
+        <p:txBody>
+          <a:bodyPr rtlCol="0" anchor="ctr"/>
+          <a:lstStyle/>
+          <a:p>
+            <a:pPr algn="ctr"/>
+          </a:p>
+        </p:txBody>
+      </p:sp>
+      <p:sp>
+        <p:nvSpPr>
+          <p:cNvPr id="13" name="TextBox 12"/>
+          <p:cNvSpPr txBox="1"/>
+          <p:nvPr/>
+        </p:nvSpPr>
+        <p:spPr>
+          <a:xfrm>
+            <a:off x="6217920" y="1600200"/>
+            <a:ext cx="2697480" cy="594360"/>
+          </a:xfrm>
+          <a:prstGeom prst="rect">
+            <a:avLst/>
+          </a:prstGeom>
+          <a:noFill/>
+        </p:spPr>
+        <p:txBody>
+          <a:bodyPr wrap="none">
+            <a:spAutoFit/>
+          </a:bodyPr>
+          <a:lstStyle/>
+          <a:p>
+            <a:pPr algn="ctr"/>
+            <a:r>
+              <a:rPr sz="2800" b="1">
+                <a:solidFill>
+                  <a:srgbClr val="16A34A"/>
+                </a:solidFill>
+              </a:rPr>
+              <a:t>95-97%</a:t>
+            </a:r>
+          </a:p>
+        </p:txBody>
+      </p:sp>
+      <p:sp>
+        <p:nvSpPr>
+          <p:cNvPr id="14" name="TextBox 13"/>
+          <p:cNvSpPr txBox="1"/>
+          <p:nvPr/>
+        </p:nvSpPr>
+        <p:spPr>
+          <a:xfrm>
+            <a:off x="6217920" y="2071116"/>
+            <a:ext cx="2697480" cy="475488"/>
+          </a:xfrm>
+          <a:prstGeom prst="rect">
+            <a:avLst/>
+          </a:prstGeom>
+          <a:noFill/>
+        </p:spPr>
+        <p:txBody>
+          <a:bodyPr wrap="none">
+            <a:spAutoFit/>
+          </a:bodyPr>
+          <a:lstStyle/>
+          <a:p>
+            <a:pPr algn="ctr"/>
+            <a:r>
+              <a:rPr sz="1100">
+                <a:solidFill>
+                  <a:srgbClr val="1F2937"/>
+                </a:solidFill>
+              </a:rPr>
+              <a:t>MTTR 改进 (Skill 复用)</a:t>
+            </a:r>
+          </a:p>
+        </p:txBody>
+      </p:sp>
+      <p:sp>
+        <p:nvSpPr>
+          <p:cNvPr id="15" name="Rounded Rectangle 14"/>
+          <p:cNvSpPr/>
+          <p:nvPr/>
+        </p:nvSpPr>
+        <p:spPr>
+          <a:xfrm>
+            <a:off x="9098280" y="1417320"/>
+            <a:ext cx="2697480" cy="1188720"/>
+          </a:xfrm>
+          <a:prstGeom prst="roundRect">
+            <a:avLst/>
+          </a:prstGeom>
+          <a:solidFill>
+            <a:srgbClr val="FFFFFF"/>
+          </a:solidFill>
+          <a:ln w="6350">
+            <a:solidFill>
+              <a:srgbClr val="E5E7EB"/>
+            </a:solidFill>
+          </a:ln>
+        </p:spPr>
+        <p:style>
+          <a:lnRef idx="1">
+            <a:schemeClr val="accent1"/>
+          </a:lnRef>
+          <a:fillRef idx="3">
+            <a:schemeClr val="accent1"/>
+          </a:fillRef>
+          <a:effectRef idx="2">
+            <a:schemeClr val="accent1"/>
+          </a:effectRef>
+          <a:fontRef idx="minor">
+            <a:schemeClr val="lt1"/>
+          </a:fontRef>
+        </p:style>
+        <p:txBody>
+          <a:bodyPr rtlCol="0" anchor="ctr"/>
+          <a:lstStyle/>
+          <a:p>
+            <a:pPr algn="ctr"/>
+          </a:p>
+        </p:txBody>
+      </p:sp>
+      <p:sp>
+        <p:nvSpPr>
+          <p:cNvPr id="16" name="TextBox 15"/>
+          <p:cNvSpPr txBox="1"/>
+          <p:nvPr/>
+        </p:nvSpPr>
+        <p:spPr>
+          <a:xfrm>
+            <a:off x="9098280" y="1600200"/>
+            <a:ext cx="2697480" cy="594360"/>
+          </a:xfrm>
+          <a:prstGeom prst="rect">
+            <a:avLst/>
+          </a:prstGeom>
+          <a:noFill/>
+        </p:spPr>
+        <p:txBody>
+          <a:bodyPr wrap="none">
+            <a:spAutoFit/>
+          </a:bodyPr>
+          <a:lstStyle/>
+          <a:p>
+            <a:pPr algn="ctr"/>
+            <a:r>
+              <a:rPr sz="2800" b="1">
+                <a:solidFill>
+                  <a:srgbClr val="DC2626"/>
+                </a:solidFill>
+              </a:rPr>
+              <a:t>&lt; 0.1%</a:t>
+            </a:r>
+          </a:p>
+        </p:txBody>
+      </p:sp>
+      <p:sp>
+        <p:nvSpPr>
+          <p:cNvPr id="17" name="TextBox 16"/>
+          <p:cNvSpPr txBox="1"/>
+          <p:nvPr/>
+        </p:nvSpPr>
+        <p:spPr>
+          <a:xfrm>
+            <a:off x="9098280" y="2071116"/>
+            <a:ext cx="2697480" cy="475488"/>
+          </a:xfrm>
+          <a:prstGeom prst="rect">
+            <a:avLst/>
+          </a:prstGeom>
+          <a:noFill/>
+        </p:spPr>
+        <p:txBody>
+          <a:bodyPr wrap="none">
+            <a:spAutoFit/>
+          </a:bodyPr>
+          <a:lstStyle/>
+          <a:p>
+            <a:pPr algn="ctr"/>
+            <a:r>
+              <a:rPr sz="1100">
+                <a:solidFill>
+                  <a:srgbClr val="1F2937"/>
+                </a:solidFill>
+              </a:rPr>
+              <a:t>Lambda 错误率</a:t>
+            </a:r>
+          </a:p>
+        </p:txBody>
+      </p:sp>
+      <p:sp>
+        <p:nvSpPr>
+          <p:cNvPr id="18" name="TextBox 17"/>
+          <p:cNvSpPr txBox="1"/>
+          <p:nvPr/>
+        </p:nvSpPr>
+        <p:spPr>
+          <a:xfrm>
+            <a:off x="457200" y="2788920"/>
             <a:ext cx="11247120" cy="365760"/>
           </a:xfrm>
           <a:prstGeom prst="rect">
@@ -8634,22 +9033,22 @@
                   <a:srgbClr val="232F3E"/>
                 </a:solidFill>
               </a:rPr>
-              <a:t>v4 5 个 MCP 工具耗时</a:t>
+              <a:t>⏱️ 告警闭环关键路径耗时分解</a:t>
             </a:r>
           </a:p>
         </p:txBody>
       </p:sp>
       <p:graphicFrame>
         <p:nvGraphicFramePr>
-          <p:cNvPr id="6" name="Table 5"/>
+          <p:cNvPr id="19" name="Table 18"/>
           <p:cNvGraphicFramePr>
             <a:graphicFrameLocks noGrp="1"/>
           </p:cNvGraphicFramePr>
           <p:nvPr/>
         </p:nvGraphicFramePr>
         <p:xfrm>
-          <a:off x="457200" y="1417320"/>
-          <a:ext cx="11247120" cy="2468880"/>
+          <a:off x="457200" y="3200400"/>
+          <a:ext cx="11247120" cy="2103120"/>
         </p:xfrm>
         <a:graphic>
           <a:graphicData uri="http://schemas.openxmlformats.org/drawingml/2006/table">
@@ -8658,11 +9057,13 @@
                 <a:tableStyleId>{5C22544A-7EE6-4342-B048-85BDC9FD1C3A}</a:tableStyleId>
               </a:tblPr>
               <a:tblGrid>
-                <a:gridCol w="3749040"/>
-                <a:gridCol w="3749040"/>
-                <a:gridCol w="3749040"/>
+                <a:gridCol w="2249424"/>
+                <a:gridCol w="2249424"/>
+                <a:gridCol w="2249424"/>
+                <a:gridCol w="2249424"/>
+                <a:gridCol w="2249424"/>
               </a:tblGrid>
-              <a:tr h="411480">
+              <a:tr h="300445">
                 <a:tc>
                   <a:txBody>
                     <a:bodyPr/>
@@ -8674,11 +9075,11 @@
                             <a:srgbClr val="FFFFFF"/>
                           </a:solidFill>
                         </a:rPr>
-                        <a:t>MCP 工具</a:t>
+                        <a:t>阶段</a:t>
                       </a:r>
                     </a:p>
                   </a:txBody>
-                  <a:tcPr marT="50800" marB="50800" marL="101600" marR="101600">
+                  <a:tcPr marT="38100" marB="38100">
                     <a:solidFill>
                       <a:srgbClr val="232F3E"/>
                     </a:solidFill>
@@ -8699,7 +9100,49 @@
                       </a:r>
                     </a:p>
                   </a:txBody>
-                  <a:tcPr marT="50800" marB="50800" marL="101600" marR="101600">
+                  <a:tcPr marT="38100" marB="38100">
+                    <a:solidFill>
+                      <a:srgbClr val="232F3E"/>
+                    </a:solidFill>
+                  </a:tcPr>
+                </a:tc>
+                <a:tc>
+                  <a:txBody>
+                    <a:bodyPr/>
+                    <a:lstStyle/>
+                    <a:p>
+                      <a:r>
+                        <a:rPr sz="1000" b="1">
+                          <a:solidFill>
+                            <a:srgbClr val="FFFFFF"/>
+                          </a:solidFill>
+                        </a:rPr>
+                        <a:t>占比</a:t>
+                      </a:r>
+                    </a:p>
+                  </a:txBody>
+                  <a:tcPr marT="38100" marB="38100">
+                    <a:solidFill>
+                      <a:srgbClr val="232F3E"/>
+                    </a:solidFill>
+                  </a:tcPr>
+                </a:tc>
+                <a:tc>
+                  <a:txBody>
+                    <a:bodyPr/>
+                    <a:lstStyle/>
+                    <a:p>
+                      <a:r>
+                        <a:rPr sz="1000" b="1">
+                          <a:solidFill>
+                            <a:srgbClr val="FFFFFF"/>
+                          </a:solidFill>
+                        </a:rPr>
+                        <a:t>瓶颈?</a:t>
+                      </a:r>
+                    </a:p>
+                  </a:txBody>
+                  <a:tcPr marT="38100" marB="38100">
                     <a:solidFill>
                       <a:srgbClr val="232F3E"/>
                     </a:solidFill>
@@ -8720,14 +9163,14 @@
                       </a:r>
                     </a:p>
                   </a:txBody>
-                  <a:tcPr marT="50800" marB="50800" marL="101600" marR="101600">
+                  <a:tcPr marT="38100" marB="38100">
                     <a:solidFill>
                       <a:srgbClr val="232F3E"/>
                     </a:solidFill>
                   </a:tcPr>
                 </a:tc>
               </a:tr>
-              <a:tr h="411480">
+              <a:tr h="300445">
                 <a:tc>
                   <a:txBody>
                     <a:bodyPr/>
@@ -8739,11 +9182,11 @@
                             <a:srgbClr val="1F2937"/>
                           </a:solidFill>
                         </a:rPr>
-                        <a:t>query_doa</a:t>
+                        <a:t>CW Alarm → SNS</a:t>
                       </a:r>
                     </a:p>
                   </a:txBody>
-                  <a:tcPr marT="50800" marB="50800" marL="101600" marR="101600"/>
+                  <a:tcPr marT="38100" marB="38100"/>
                 </a:tc>
                 <a:tc>
                   <a:txBody>
@@ -8756,11 +9199,11 @@
                             <a:srgbClr val="1F2937"/>
                           </a:solidFill>
                         </a:rPr>
-                        <a:t>5-30s</a:t>
+                        <a:t>&lt; 1s</a:t>
                       </a:r>
                     </a:p>
                   </a:txBody>
-                  <a:tcPr marT="50800" marB="50800" marL="101600" marR="101600"/>
+                  <a:tcPr marT="38100" marB="38100"/>
                 </a:tc>
                 <a:tc>
                   <a:txBody>
@@ -8773,14 +9216,12 @@
                             <a:srgbClr val="1F2937"/>
                           </a:solidFill>
                         </a:rPr>
-                        <a:t>受 DOA Chat 时间影响,API GW 29s 限制</a:t>
+                        <a:t>&lt;1%</a:t>
                       </a:r>
                     </a:p>
                   </a:txBody>
-                  <a:tcPr marT="50800" marB="50800" marL="101600" marR="101600"/>
+                  <a:tcPr marT="38100" marB="38100"/>
                 </a:tc>
-              </a:tr>
-              <a:tr h="411480">
                 <a:tc>
                   <a:txBody>
                     <a:bodyPr/>
@@ -8792,11 +9233,47 @@
                             <a:srgbClr val="1F2937"/>
                           </a:solidFill>
                         </a:rPr>
-                        <a:t>start_investigation</a:t>
+                        <a:t>❌</a:t>
                       </a:r>
                     </a:p>
                   </a:txBody>
-                  <a:tcPr marT="50800" marB="50800" marL="101600" marR="101600">
+                  <a:tcPr marT="38100" marB="38100"/>
+                </a:tc>
+                <a:tc>
+                  <a:txBody>
+                    <a:bodyPr/>
+                    <a:lstStyle/>
+                    <a:p>
+                      <a:r>
+                        <a:rPr sz="1000">
+                          <a:solidFill>
+                            <a:srgbClr val="1F2937"/>
+                          </a:solidFill>
+                        </a:rPr>
+                        <a:t>AWS 内部</a:t>
+                      </a:r>
+                    </a:p>
+                  </a:txBody>
+                  <a:tcPr marT="38100" marB="38100"/>
+                </a:tc>
+              </a:tr>
+              <a:tr h="300445">
+                <a:tc>
+                  <a:txBody>
+                    <a:bodyPr/>
+                    <a:lstStyle/>
+                    <a:p>
+                      <a:r>
+                        <a:rPr sz="1000">
+                          <a:solidFill>
+                            <a:srgbClr val="1F2937"/>
+                          </a:solidFill>
+                        </a:rPr>
+                        <a:t>SNS → Lambda</a:t>
+                      </a:r>
+                    </a:p>
+                  </a:txBody>
+                  <a:tcPr marT="38100" marB="38100">
                     <a:solidFill>
                       <a:srgbClr val="F7F8FA"/>
                     </a:solidFill>
@@ -8813,11 +9290,11 @@
                             <a:srgbClr val="1F2937"/>
                           </a:solidFill>
                         </a:rPr>
-                        <a:t>~2s</a:t>
+                        <a:t>&lt; 100ms</a:t>
                       </a:r>
                     </a:p>
                   </a:txBody>
-                  <a:tcPr marT="50800" marB="50800" marL="101600" marR="101600">
+                  <a:tcPr marT="38100" marB="38100">
                     <a:solidFill>
                       <a:srgbClr val="F7F8FA"/>
                     </a:solidFill>
@@ -8834,87 +9311,11 @@
                             <a:srgbClr val="1F2937"/>
                           </a:solidFill>
                         </a:rPr>
-                        <a:t>异步,立即返回 task_id</a:t>
+                        <a:t>&lt;1%</a:t>
                       </a:r>
                     </a:p>
                   </a:txBody>
-                  <a:tcPr marT="50800" marB="50800" marL="101600" marR="101600">
-                    <a:solidFill>
-                      <a:srgbClr val="F7F8FA"/>
-                    </a:solidFill>
-                  </a:tcPr>
-                </a:tc>
-              </a:tr>
-              <a:tr h="411480">
-                <a:tc>
-                  <a:txBody>
-                    <a:bodyPr/>
-                    <a:lstStyle/>
-                    <a:p>
-                      <a:r>
-                        <a:rPr sz="1000">
-                          <a:solidFill>
-                            <a:srgbClr val="1F2937"/>
-                          </a:solidFill>
-                        </a:rPr>
-                        <a:t>get_html_report</a:t>
-                      </a:r>
-                    </a:p>
-                  </a:txBody>
-                  <a:tcPr marT="50800" marB="50800" marL="101600" marR="101600"/>
-                </a:tc>
-                <a:tc>
-                  <a:txBody>
-                    <a:bodyPr/>
-                    <a:lstStyle/>
-                    <a:p>
-                      <a:r>
-                        <a:rPr sz="1000">
-                          <a:solidFill>
-                            <a:srgbClr val="1F2937"/>
-                          </a:solidFill>
-                        </a:rPr>
-                        <a:t>3-5s</a:t>
-                      </a:r>
-                    </a:p>
-                  </a:txBody>
-                  <a:tcPr marT="50800" marB="50800" marL="101600" marR="101600"/>
-                </a:tc>
-                <a:tc>
-                  <a:txBody>
-                    <a:bodyPr/>
-                    <a:lstStyle/>
-                    <a:p>
-                      <a:r>
-                        <a:rPr sz="1000">
-                          <a:solidFill>
-                            <a:srgbClr val="1F2937"/>
-                          </a:solidFill>
-                        </a:rPr>
-                        <a:t>GetBacklogTask + ListJournalRecords + Jinja2</a:t>
-                      </a:r>
-                    </a:p>
-                  </a:txBody>
-                  <a:tcPr marT="50800" marB="50800" marL="101600" marR="101600"/>
-                </a:tc>
-              </a:tr>
-              <a:tr h="411480">
-                <a:tc>
-                  <a:txBody>
-                    <a:bodyPr/>
-                    <a:lstStyle/>
-                    <a:p>
-                      <a:r>
-                        <a:rPr sz="1000">
-                          <a:solidFill>
-                            <a:srgbClr val="1F2937"/>
-                          </a:solidFill>
-                        </a:rPr>
-                        <a:t>trigger_runbook</a:t>
-                      </a:r>
-                    </a:p>
-                  </a:txBody>
-                  <a:tcPr marT="50800" marB="50800" marL="101600" marR="101600">
+                  <a:tcPr marT="38100" marB="38100">
                     <a:solidFill>
                       <a:srgbClr val="F7F8FA"/>
                     </a:solidFill>
@@ -8931,11 +9332,11 @@
                             <a:srgbClr val="1F2937"/>
                           </a:solidFill>
                         </a:rPr>
-                        <a:t>1-3s</a:t>
+                        <a:t>❌</a:t>
                       </a:r>
                     </a:p>
                   </a:txBody>
-                  <a:tcPr marT="50800" marB="50800" marL="101600" marR="101600">
+                  <a:tcPr marT="38100" marB="38100">
                     <a:solidFill>
                       <a:srgbClr val="F7F8FA"/>
                     </a:solidFill>
@@ -8952,18 +9353,18 @@
                             <a:srgbClr val="1F2937"/>
                           </a:solidFill>
                         </a:rPr>
-                        <a:t>SSM StartAutomationExecution</a:t>
+                        <a:t>事件触发</a:t>
                       </a:r>
                     </a:p>
                   </a:txBody>
-                  <a:tcPr marT="50800" marB="50800" marL="101600" marR="101600">
+                  <a:tcPr marT="38100" marB="38100">
                     <a:solidFill>
                       <a:srgbClr val="F7F8FA"/>
                     </a:solidFill>
                   </a:tcPr>
                 </a:tc>
               </a:tr>
-              <a:tr h="411480">
+              <a:tr h="300445">
                 <a:tc>
                   <a:txBody>
                     <a:bodyPr/>
@@ -8975,11 +9376,296 @@
                             <a:srgbClr val="1F2937"/>
                           </a:solidFill>
                         </a:rPr>
-                        <a:t>notify_im</a:t>
+                        <a:t>Lambda → DOA</a:t>
                       </a:r>
                     </a:p>
                   </a:txBody>
-                  <a:tcPr marT="50800" marB="50800" marL="101600" marR="101600"/>
+                  <a:tcPr marT="38100" marB="38100"/>
+                </a:tc>
+                <a:tc>
+                  <a:txBody>
+                    <a:bodyPr/>
+                    <a:lstStyle/>
+                    <a:p>
+                      <a:r>
+                        <a:rPr sz="1000">
+                          <a:solidFill>
+                            <a:srgbClr val="1F2937"/>
+                          </a:solidFill>
+                        </a:rPr>
+                        <a:t>~2s</a:t>
+                      </a:r>
+                    </a:p>
+                  </a:txBody>
+                  <a:tcPr marT="38100" marB="38100"/>
+                </a:tc>
+                <a:tc>
+                  <a:txBody>
+                    <a:bodyPr/>
+                    <a:lstStyle/>
+                    <a:p>
+                      <a:r>
+                        <a:rPr sz="1000">
+                          <a:solidFill>
+                            <a:srgbClr val="1F2937"/>
+                          </a:solidFill>
+                        </a:rPr>
+                        <a:t>&lt;1%</a:t>
+                      </a:r>
+                    </a:p>
+                  </a:txBody>
+                  <a:tcPr marT="38100" marB="38100"/>
+                </a:tc>
+                <a:tc>
+                  <a:txBody>
+                    <a:bodyPr/>
+                    <a:lstStyle/>
+                    <a:p>
+                      <a:r>
+                        <a:rPr sz="1000">
+                          <a:solidFill>
+                            <a:srgbClr val="1F2937"/>
+                          </a:solidFill>
+                        </a:rPr>
+                        <a:t>❌</a:t>
+                      </a:r>
+                    </a:p>
+                  </a:txBody>
+                  <a:tcPr marT="38100" marB="38100"/>
+                </a:tc>
+                <a:tc>
+                  <a:txBody>
+                    <a:bodyPr/>
+                    <a:lstStyle/>
+                    <a:p>
+                      <a:r>
+                        <a:rPr sz="1000">
+                          <a:solidFill>
+                            <a:srgbClr val="1F2937"/>
+                          </a:solidFill>
+                        </a:rPr>
+                        <a:t>boto3 调用</a:t>
+                      </a:r>
+                    </a:p>
+                  </a:txBody>
+                  <a:tcPr marT="38100" marB="38100"/>
+                </a:tc>
+              </a:tr>
+              <a:tr h="300445">
+                <a:tc>
+                  <a:txBody>
+                    <a:bodyPr/>
+                    <a:lstStyle/>
+                    <a:p>
+                      <a:r>
+                        <a:rPr sz="1000" b="1">
+                          <a:solidFill>
+                            <a:srgbClr val="1F2937"/>
+                          </a:solidFill>
+                        </a:rPr>
+                        <a:t>DOA Investigation</a:t>
+                      </a:r>
+                    </a:p>
+                  </a:txBody>
+                  <a:tcPr marT="38100" marB="38100">
+                    <a:solidFill>
+                      <a:srgbClr val="FFF7ED"/>
+                    </a:solidFill>
+                  </a:tcPr>
+                </a:tc>
+                <a:tc>
+                  <a:txBody>
+                    <a:bodyPr/>
+                    <a:lstStyle/>
+                    <a:p>
+                      <a:r>
+                        <a:rPr sz="1000" b="1">
+                          <a:solidFill>
+                            <a:srgbClr val="1F2937"/>
+                          </a:solidFill>
+                        </a:rPr>
+                        <a:t>5-15 min</a:t>
+                      </a:r>
+                    </a:p>
+                  </a:txBody>
+                  <a:tcPr marT="38100" marB="38100">
+                    <a:solidFill>
+                      <a:srgbClr val="FFF7ED"/>
+                    </a:solidFill>
+                  </a:tcPr>
+                </a:tc>
+                <a:tc>
+                  <a:txBody>
+                    <a:bodyPr/>
+                    <a:lstStyle/>
+                    <a:p>
+                      <a:r>
+                        <a:rPr sz="1000" b="1">
+                          <a:solidFill>
+                            <a:srgbClr val="1F2937"/>
+                          </a:solidFill>
+                        </a:rPr>
+                        <a:t>~99%</a:t>
+                      </a:r>
+                    </a:p>
+                  </a:txBody>
+                  <a:tcPr marT="38100" marB="38100">
+                    <a:solidFill>
+                      <a:srgbClr val="FFF7ED"/>
+                    </a:solidFill>
+                  </a:tcPr>
+                </a:tc>
+                <a:tc>
+                  <a:txBody>
+                    <a:bodyPr/>
+                    <a:lstStyle/>
+                    <a:p>
+                      <a:r>
+                        <a:rPr sz="1000" b="1">
+                          <a:solidFill>
+                            <a:srgbClr val="1F2937"/>
+                          </a:solidFill>
+                        </a:rPr>
+                        <a:t>⭐ 主要</a:t>
+                      </a:r>
+                    </a:p>
+                  </a:txBody>
+                  <a:tcPr marT="38100" marB="38100">
+                    <a:solidFill>
+                      <a:srgbClr val="FFF7ED"/>
+                    </a:solidFill>
+                  </a:tcPr>
+                </a:tc>
+                <a:tc>
+                  <a:txBody>
+                    <a:bodyPr/>
+                    <a:lstStyle/>
+                    <a:p>
+                      <a:r>
+                        <a:rPr sz="1000" b="1">
+                          <a:solidFill>
+                            <a:srgbClr val="1F2937"/>
+                          </a:solidFill>
+                        </a:rPr>
+                        <a:t>AI 跨源关联调查</a:t>
+                      </a:r>
+                    </a:p>
+                  </a:txBody>
+                  <a:tcPr marT="38100" marB="38100">
+                    <a:solidFill>
+                      <a:srgbClr val="FFF7ED"/>
+                    </a:solidFill>
+                  </a:tcPr>
+                </a:tc>
+              </a:tr>
+              <a:tr h="300445">
+                <a:tc>
+                  <a:txBody>
+                    <a:bodyPr/>
+                    <a:lstStyle/>
+                    <a:p>
+                      <a:r>
+                        <a:rPr sz="1000">
+                          <a:solidFill>
+                            <a:srgbClr val="1F2937"/>
+                          </a:solidFill>
+                        </a:rPr>
+                        <a:t>EB → Lambda 渲染</a:t>
+                      </a:r>
+                    </a:p>
+                  </a:txBody>
+                  <a:tcPr marT="38100" marB="38100"/>
+                </a:tc>
+                <a:tc>
+                  <a:txBody>
+                    <a:bodyPr/>
+                    <a:lstStyle/>
+                    <a:p>
+                      <a:r>
+                        <a:rPr sz="1000">
+                          <a:solidFill>
+                            <a:srgbClr val="1F2937"/>
+                          </a:solidFill>
+                        </a:rPr>
+                        <a:t>5-10s</a:t>
+                      </a:r>
+                    </a:p>
+                  </a:txBody>
+                  <a:tcPr marT="38100" marB="38100"/>
+                </a:tc>
+                <a:tc>
+                  <a:txBody>
+                    <a:bodyPr/>
+                    <a:lstStyle/>
+                    <a:p>
+                      <a:r>
+                        <a:rPr sz="1000">
+                          <a:solidFill>
+                            <a:srgbClr val="1F2937"/>
+                          </a:solidFill>
+                        </a:rPr>
+                        <a:t>&lt;1%</a:t>
+                      </a:r>
+                    </a:p>
+                  </a:txBody>
+                  <a:tcPr marT="38100" marB="38100"/>
+                </a:tc>
+                <a:tc>
+                  <a:txBody>
+                    <a:bodyPr/>
+                    <a:lstStyle/>
+                    <a:p>
+                      <a:r>
+                        <a:rPr sz="1000">
+                          <a:solidFill>
+                            <a:srgbClr val="1F2937"/>
+                          </a:solidFill>
+                        </a:rPr>
+                        <a:t>❌</a:t>
+                      </a:r>
+                    </a:p>
+                  </a:txBody>
+                  <a:tcPr marT="38100" marB="38100"/>
+                </a:tc>
+                <a:tc>
+                  <a:txBody>
+                    <a:bodyPr/>
+                    <a:lstStyle/>
+                    <a:p>
+                      <a:r>
+                        <a:rPr sz="1000">
+                          <a:solidFill>
+                            <a:srgbClr val="1F2937"/>
+                          </a:solidFill>
+                        </a:rPr>
+                        <a:t>Nova Pro 并行增强</a:t>
+                      </a:r>
+                    </a:p>
+                  </a:txBody>
+                  <a:tcPr marT="38100" marB="38100"/>
+                </a:tc>
+              </a:tr>
+              <a:tr h="300450">
+                <a:tc>
+                  <a:txBody>
+                    <a:bodyPr/>
+                    <a:lstStyle/>
+                    <a:p>
+                      <a:r>
+                        <a:rPr sz="1000">
+                          <a:solidFill>
+                            <a:srgbClr val="1F2937"/>
+                          </a:solidFill>
+                        </a:rPr>
+                        <a:t>飞书 + 邮件推送</a:t>
+                      </a:r>
+                    </a:p>
+                  </a:txBody>
+                  <a:tcPr marT="38100" marB="38100">
+                    <a:solidFill>
+                      <a:srgbClr val="F7F8FA"/>
+                    </a:solidFill>
+                  </a:tcPr>
                 </a:tc>
                 <a:tc>
                   <a:txBody>
@@ -8996,260 +9682,7 @@
                       </a:r>
                     </a:p>
                   </a:txBody>
-                  <a:tcPr marT="50800" marB="50800" marL="101600" marR="101600"/>
-                </a:tc>
-                <a:tc>
-                  <a:txBody>
-                    <a:bodyPr/>
-                    <a:lstStyle/>
-                    <a:p>
-                      <a:r>
-                        <a:rPr sz="1000">
-                          <a:solidFill>
-                            <a:srgbClr val="1F2937"/>
-                          </a:solidFill>
-                        </a:rPr>
-                        <a:t>SES SendEmail / 飞书 Webhook POST</a:t>
-                      </a:r>
-                    </a:p>
-                  </a:txBody>
-                  <a:tcPr marT="50800" marB="50800" marL="101600" marR="101600"/>
-                </a:tc>
-              </a:tr>
-            </a:tbl>
-          </a:graphicData>
-        </a:graphic>
-      </p:graphicFrame>
-      <p:sp>
-        <p:nvSpPr>
-          <p:cNvPr id="7" name="TextBox 6"/>
-          <p:cNvSpPr txBox="1"/>
-          <p:nvPr/>
-        </p:nvSpPr>
-        <p:spPr>
-          <a:xfrm>
-            <a:off x="457200" y="4114800"/>
-            <a:ext cx="11247120" cy="365760"/>
-          </a:xfrm>
-          <a:prstGeom prst="rect">
-            <a:avLst/>
-          </a:prstGeom>
-          <a:noFill/>
-        </p:spPr>
-        <p:txBody>
-          <a:bodyPr wrap="square">
-            <a:spAutoFit/>
-          </a:bodyPr>
-          <a:lstStyle/>
-          <a:p>
-            <a:r>
-              <a:rPr sz="1400" b="1">
-                <a:solidFill>
-                  <a:srgbClr val="232F3E"/>
-                </a:solidFill>
-              </a:rPr>
-              <a:t>v3 vs v4 精简对比</a:t>
-            </a:r>
-          </a:p>
-        </p:txBody>
-      </p:sp>
-      <p:graphicFrame>
-        <p:nvGraphicFramePr>
-          <p:cNvPr id="8" name="Table 7"/>
-          <p:cNvGraphicFramePr>
-            <a:graphicFrameLocks noGrp="1"/>
-          </p:cNvGraphicFramePr>
-          <p:nvPr/>
-        </p:nvGraphicFramePr>
-        <p:xfrm>
-          <a:off x="457200" y="4572000"/>
-          <a:ext cx="11247120" cy="1645920"/>
-        </p:xfrm>
-        <a:graphic>
-          <a:graphicData uri="http://schemas.openxmlformats.org/drawingml/2006/table">
-            <a:tbl>
-              <a:tblPr firstRow="1" bandRow="1">
-                <a:tableStyleId>{5C22544A-7EE6-4342-B048-85BDC9FD1C3A}</a:tableStyleId>
-              </a:tblPr>
-              <a:tblGrid>
-                <a:gridCol w="2811780"/>
-                <a:gridCol w="2811780"/>
-                <a:gridCol w="2811780"/>
-                <a:gridCol w="2811780"/>
-              </a:tblGrid>
-              <a:tr h="329184">
-                <a:tc>
-                  <a:txBody>
-                    <a:bodyPr/>
-                    <a:lstStyle/>
-                    <a:p>
-                      <a:r>
-                        <a:rPr sz="1000" b="1">
-                          <a:solidFill>
-                            <a:srgbClr val="FFFFFF"/>
-                          </a:solidFill>
-                        </a:rPr>
-                        <a:t>维度</a:t>
-                      </a:r>
-                    </a:p>
-                  </a:txBody>
-                  <a:tcPr marT="50800" marB="50800" marL="101600" marR="101600">
-                    <a:solidFill>
-                      <a:srgbClr val="232F3E"/>
-                    </a:solidFill>
-                  </a:tcPr>
-                </a:tc>
-                <a:tc>
-                  <a:txBody>
-                    <a:bodyPr/>
-                    <a:lstStyle/>
-                    <a:p>
-                      <a:r>
-                        <a:rPr sz="1000" b="1">
-                          <a:solidFill>
-                            <a:srgbClr val="FFFFFF"/>
-                          </a:solidFill>
-                        </a:rPr>
-                        <a:t>v3</a:t>
-                      </a:r>
-                    </a:p>
-                  </a:txBody>
-                  <a:tcPr marT="50800" marB="50800" marL="101600" marR="101600">
-                    <a:solidFill>
-                      <a:srgbClr val="232F3E"/>
-                    </a:solidFill>
-                  </a:tcPr>
-                </a:tc>
-                <a:tc>
-                  <a:txBody>
-                    <a:bodyPr/>
-                    <a:lstStyle/>
-                    <a:p>
-                      <a:r>
-                        <a:rPr sz="1000" b="1">
-                          <a:solidFill>
-                            <a:srgbClr val="FFFFFF"/>
-                          </a:solidFill>
-                        </a:rPr>
-                        <a:t>v4</a:t>
-                      </a:r>
-                    </a:p>
-                  </a:txBody>
-                  <a:tcPr marT="50800" marB="50800" marL="101600" marR="101600">
-                    <a:solidFill>
-                      <a:srgbClr val="232F3E"/>
-                    </a:solidFill>
-                  </a:tcPr>
-                </a:tc>
-                <a:tc>
-                  <a:txBody>
-                    <a:bodyPr/>
-                    <a:lstStyle/>
-                    <a:p>
-                      <a:r>
-                        <a:rPr sz="1000" b="1">
-                          <a:solidFill>
-                            <a:srgbClr val="FFFFFF"/>
-                          </a:solidFill>
-                        </a:rPr>
-                        <a:t>变化</a:t>
-                      </a:r>
-                    </a:p>
-                  </a:txBody>
-                  <a:tcPr marT="50800" marB="50800" marL="101600" marR="101600">
-                    <a:solidFill>
-                      <a:srgbClr val="232F3E"/>
-                    </a:solidFill>
-                  </a:tcPr>
-                </a:tc>
-              </a:tr>
-              <a:tr h="329184">
-                <a:tc>
-                  <a:txBody>
-                    <a:bodyPr/>
-                    <a:lstStyle/>
-                    <a:p>
-                      <a:r>
-                        <a:rPr sz="1000">
-                          <a:solidFill>
-                            <a:srgbClr val="1F2937"/>
-                          </a:solidFill>
-                        </a:rPr>
-                        <a:t>Lambda 数量</a:t>
-                      </a:r>
-                    </a:p>
-                  </a:txBody>
-                  <a:tcPr marT="50800" marB="50800" marL="101600" marR="101600"/>
-                </a:tc>
-                <a:tc>
-                  <a:txBody>
-                    <a:bodyPr/>
-                    <a:lstStyle/>
-                    <a:p>
-                      <a:r>
-                        <a:rPr sz="1000">
-                          <a:solidFill>
-                            <a:srgbClr val="1F2937"/>
-                          </a:solidFill>
-                        </a:rPr>
-                        <a:t>2</a:t>
-                      </a:r>
-                    </a:p>
-                  </a:txBody>
-                  <a:tcPr marT="50800" marB="50800" marL="101600" marR="101600"/>
-                </a:tc>
-                <a:tc>
-                  <a:txBody>
-                    <a:bodyPr/>
-                    <a:lstStyle/>
-                    <a:p>
-                      <a:r>
-                        <a:rPr sz="1000">
-                          <a:solidFill>
-                            <a:srgbClr val="1F2937"/>
-                          </a:solidFill>
-                        </a:rPr>
-                        <a:t>1</a:t>
-                      </a:r>
-                    </a:p>
-                  </a:txBody>
-                  <a:tcPr marT="50800" marB="50800" marL="101600" marR="101600"/>
-                </a:tc>
-                <a:tc>
-                  <a:txBody>
-                    <a:bodyPr/>
-                    <a:lstStyle/>
-                    <a:p>
-                      <a:r>
-                        <a:rPr sz="1000">
-                          <a:solidFill>
-                            <a:srgbClr val="1F2937"/>
-                          </a:solidFill>
-                        </a:rPr>
-                        <a:t>-50%</a:t>
-                      </a:r>
-                    </a:p>
-                  </a:txBody>
-                  <a:tcPr marT="50800" marB="50800" marL="101600" marR="101600"/>
-                </a:tc>
-              </a:tr>
-              <a:tr h="329184">
-                <a:tc>
-                  <a:txBody>
-                    <a:bodyPr/>
-                    <a:lstStyle/>
-                    <a:p>
-                      <a:r>
-                        <a:rPr sz="1000">
-                          <a:solidFill>
-                            <a:srgbClr val="1F2937"/>
-                          </a:solidFill>
-                        </a:rPr>
-                        <a:t>MCP 工具数</a:t>
-                      </a:r>
-                    </a:p>
-                  </a:txBody>
-                  <a:tcPr marT="50800" marB="50800" marL="101600" marR="101600">
+                  <a:tcPr marT="38100" marB="38100">
                     <a:solidFill>
                       <a:srgbClr val="F7F8FA"/>
                     </a:solidFill>
@@ -9266,11 +9699,11 @@
                             <a:srgbClr val="1F2937"/>
                           </a:solidFill>
                         </a:rPr>
-                        <a:t>21</a:t>
+                        <a:t>&lt;1%</a:t>
                       </a:r>
                     </a:p>
                   </a:txBody>
-                  <a:tcPr marT="50800" marB="50800" marL="101600" marR="101600">
+                  <a:tcPr marT="38100" marB="38100">
                     <a:solidFill>
                       <a:srgbClr val="F7F8FA"/>
                     </a:solidFill>
@@ -9287,11 +9720,11 @@
                             <a:srgbClr val="1F2937"/>
                           </a:solidFill>
                         </a:rPr>
-                        <a:t>5</a:t>
+                        <a:t>❌</a:t>
                       </a:r>
                     </a:p>
                   </a:txBody>
-                  <a:tcPr marT="50800" marB="50800" marL="101600" marR="101600">
+                  <a:tcPr marT="38100" marB="38100">
                     <a:solidFill>
                       <a:srgbClr val="F7F8FA"/>
                     </a:solidFill>
@@ -9308,34 +9741,98 @@
                             <a:srgbClr val="1F2937"/>
                           </a:solidFill>
                         </a:rPr>
-                        <a:t>-76%</a:t>
+                        <a:t>双通道并行</a:t>
                       </a:r>
                     </a:p>
                   </a:txBody>
-                  <a:tcPr marT="50800" marB="50800" marL="101600" marR="101600">
+                  <a:tcPr marT="38100" marB="38100">
                     <a:solidFill>
                       <a:srgbClr val="F7F8FA"/>
                     </a:solidFill>
                   </a:tcPr>
                 </a:tc>
               </a:tr>
-              <a:tr h="329184">
+            </a:tbl>
+          </a:graphicData>
+        </a:graphic>
+      </p:graphicFrame>
+      <p:sp>
+        <p:nvSpPr>
+          <p:cNvPr id="20" name="TextBox 19"/>
+          <p:cNvSpPr txBox="1"/>
+          <p:nvPr/>
+        </p:nvSpPr>
+        <p:spPr>
+          <a:xfrm>
+            <a:off x="457200" y="5486400"/>
+            <a:ext cx="5486400" cy="365760"/>
+          </a:xfrm>
+          <a:prstGeom prst="rect">
+            <a:avLst/>
+          </a:prstGeom>
+          <a:noFill/>
+        </p:spPr>
+        <p:txBody>
+          <a:bodyPr wrap="square">
+            <a:spAutoFit/>
+          </a:bodyPr>
+          <a:lstStyle/>
+          <a:p>
+            <a:r>
+              <a:rPr sz="1200" b="1">
+                <a:solidFill>
+                  <a:srgbClr val="232F3E"/>
+                </a:solidFill>
+              </a:rPr>
+              <a:t>🛠️ 5 个 MCP 工具耗时</a:t>
+            </a:r>
+          </a:p>
+        </p:txBody>
+      </p:sp>
+      <p:graphicFrame>
+        <p:nvGraphicFramePr>
+          <p:cNvPr id="21" name="Table 20"/>
+          <p:cNvGraphicFramePr>
+            <a:graphicFrameLocks noGrp="1"/>
+          </p:cNvGraphicFramePr>
+          <p:nvPr/>
+        </p:nvGraphicFramePr>
+        <p:xfrm>
+          <a:off x="457200" y="5852160"/>
+          <a:ext cx="5486400" cy="914400"/>
+        </p:xfrm>
+        <a:graphic>
+          <a:graphicData uri="http://schemas.openxmlformats.org/drawingml/2006/table">
+            <a:tbl>
+              <a:tblPr firstRow="1" bandRow="1">
+                <a:tableStyleId>{5C22544A-7EE6-4342-B048-85BDC9FD1C3A}</a:tableStyleId>
+              </a:tblPr>
+              <a:tblGrid>
+                <a:gridCol w="1828800"/>
+                <a:gridCol w="1828800"/>
+                <a:gridCol w="1828800"/>
+              </a:tblGrid>
+              <a:tr h="152400">
                 <a:tc>
                   <a:txBody>
                     <a:bodyPr/>
                     <a:lstStyle/>
                     <a:p>
                       <a:r>
-                        <a:rPr sz="1000">
+                        <a:rPr sz="900" b="1">
                           <a:solidFill>
-                            <a:srgbClr val="1F2937"/>
+                            <a:srgbClr val="FFFFFF"/>
                           </a:solidFill>
                         </a:rPr>
-                        <a:t>代码行数</a:t>
+                        <a:t>工具</a:t>
                       </a:r>
                     </a:p>
                   </a:txBody>
-                  <a:tcPr marT="50800" marB="50800" marL="101600" marR="101600"/>
+                  <a:tcPr marT="25400" marB="25400">
+                    <a:solidFill>
+                      <a:srgbClr val="232F3E"/>
+                    </a:solidFill>
+                  </a:tcPr>
                 </a:tc>
                 <a:tc>
                   <a:txBody>
@@ -9343,16 +9840,20 @@
                     <a:lstStyle/>
                     <a:p>
                       <a:r>
-                        <a:rPr sz="1000">
+                        <a:rPr sz="900" b="1">
                           <a:solidFill>
-                            <a:srgbClr val="1F2937"/>
+                            <a:srgbClr val="FFFFFF"/>
                           </a:solidFill>
                         </a:rPr>
-                        <a:t>~3000</a:t>
+                        <a:t>耗时</a:t>
                       </a:r>
                     </a:p>
                   </a:txBody>
-                  <a:tcPr marT="50800" marB="50800" marL="101600" marR="101600"/>
+                  <a:tcPr marT="25400" marB="25400">
+                    <a:solidFill>
+                      <a:srgbClr val="232F3E"/>
+                    </a:solidFill>
+                  </a:tcPr>
                 </a:tc>
                 <a:tc>
                   <a:txBody>
@@ -9360,16 +9861,39 @@
                     <a:lstStyle/>
                     <a:p>
                       <a:r>
-                        <a:rPr sz="1000">
+                        <a:rPr sz="900" b="1">
+                          <a:solidFill>
+                            <a:srgbClr val="FFFFFF"/>
+                          </a:solidFill>
+                        </a:rPr>
+                        <a:t>类型</a:t>
+                      </a:r>
+                    </a:p>
+                  </a:txBody>
+                  <a:tcPr marT="25400" marB="25400">
+                    <a:solidFill>
+                      <a:srgbClr val="232F3E"/>
+                    </a:solidFill>
+                  </a:tcPr>
+                </a:tc>
+              </a:tr>
+              <a:tr h="152400">
+                <a:tc>
+                  <a:txBody>
+                    <a:bodyPr/>
+                    <a:lstStyle/>
+                    <a:p>
+                      <a:r>
+                        <a:rPr sz="900">
                           <a:solidFill>
                             <a:srgbClr val="1F2937"/>
                           </a:solidFill>
                         </a:rPr>
-                        <a:t>~800</a:t>
+                        <a:t>query_doa</a:t>
                       </a:r>
                     </a:p>
                   </a:txBody>
-                  <a:tcPr marT="50800" marB="50800" marL="101600" marR="101600"/>
+                  <a:tcPr marT="25400" marB="25400"/>
                 </a:tc>
                 <a:tc>
                   <a:txBody>
@@ -9377,35 +9901,52 @@
                     <a:lstStyle/>
                     <a:p>
                       <a:r>
-                        <a:rPr sz="1000">
+                        <a:rPr sz="900">
                           <a:solidFill>
                             <a:srgbClr val="1F2937"/>
                           </a:solidFill>
                         </a:rPr>
-                        <a:t>-73%</a:t>
+                        <a:t>5-30s</a:t>
                       </a:r>
                     </a:p>
                   </a:txBody>
-                  <a:tcPr marT="50800" marB="50800" marL="101600" marR="101600"/>
+                  <a:tcPr marT="25400" marB="25400"/>
                 </a:tc>
-              </a:tr>
-              <a:tr h="329184">
                 <a:tc>
                   <a:txBody>
                     <a:bodyPr/>
                     <a:lstStyle/>
                     <a:p>
                       <a:r>
-                        <a:rPr sz="1000">
+                        <a:rPr sz="900">
                           <a:solidFill>
                             <a:srgbClr val="1F2937"/>
                           </a:solidFill>
                         </a:rPr>
-                        <a:t>月成本</a:t>
+                        <a:t>同步</a:t>
                       </a:r>
                     </a:p>
                   </a:txBody>
-                  <a:tcPr marT="50800" marB="50800" marL="101600" marR="101600">
+                  <a:tcPr marT="25400" marB="25400"/>
+                </a:tc>
+              </a:tr>
+              <a:tr h="152400">
+                <a:tc>
+                  <a:txBody>
+                    <a:bodyPr/>
+                    <a:lstStyle/>
+                    <a:p>
+                      <a:r>
+                        <a:rPr sz="900">
+                          <a:solidFill>
+                            <a:srgbClr val="1F2937"/>
+                          </a:solidFill>
+                        </a:rPr>
+                        <a:t>start_investigation</a:t>
+                      </a:r>
+                    </a:p>
+                  </a:txBody>
+                  <a:tcPr marT="25400" marB="25400">
                     <a:solidFill>
                       <a:srgbClr val="F7F8FA"/>
                     </a:solidFill>
@@ -9417,16 +9958,16 @@
                     <a:lstStyle/>
                     <a:p>
                       <a:r>
-                        <a:rPr sz="1000">
+                        <a:rPr sz="900">
                           <a:solidFill>
                             <a:srgbClr val="1F2937"/>
                           </a:solidFill>
                         </a:rPr>
-                        <a:t>$1,682</a:t>
+                        <a:t>~2s</a:t>
                       </a:r>
                     </a:p>
                   </a:txBody>
-                  <a:tcPr marT="50800" marB="50800" marL="101600" marR="101600">
+                  <a:tcPr marT="25400" marB="25400">
                     <a:solidFill>
                       <a:srgbClr val="F7F8FA"/>
                     </a:solidFill>
@@ -9438,16 +9979,92 @@
                     <a:lstStyle/>
                     <a:p>
                       <a:r>
-                        <a:rPr sz="1000">
+                        <a:rPr sz="900">
                           <a:solidFill>
                             <a:srgbClr val="1F2937"/>
                           </a:solidFill>
                         </a:rPr>
-                        <a:t>$452</a:t>
+                        <a:t>异步</a:t>
                       </a:r>
                     </a:p>
                   </a:txBody>
-                  <a:tcPr marT="50800" marB="50800" marL="101600" marR="101600">
+                  <a:tcPr marT="25400" marB="25400">
+                    <a:solidFill>
+                      <a:srgbClr val="F7F8FA"/>
+                    </a:solidFill>
+                  </a:tcPr>
+                </a:tc>
+              </a:tr>
+              <a:tr h="152400">
+                <a:tc>
+                  <a:txBody>
+                    <a:bodyPr/>
+                    <a:lstStyle/>
+                    <a:p>
+                      <a:r>
+                        <a:rPr sz="900">
+                          <a:solidFill>
+                            <a:srgbClr val="1F2937"/>
+                          </a:solidFill>
+                        </a:rPr>
+                        <a:t>get_html_report</a:t>
+                      </a:r>
+                    </a:p>
+                  </a:txBody>
+                  <a:tcPr marT="25400" marB="25400"/>
+                </a:tc>
+                <a:tc>
+                  <a:txBody>
+                    <a:bodyPr/>
+                    <a:lstStyle/>
+                    <a:p>
+                      <a:r>
+                        <a:rPr sz="900">
+                          <a:solidFill>
+                            <a:srgbClr val="1F2937"/>
+                          </a:solidFill>
+                        </a:rPr>
+                        <a:t>3-5s</a:t>
+                      </a:r>
+                    </a:p>
+                  </a:txBody>
+                  <a:tcPr marT="25400" marB="25400"/>
+                </a:tc>
+                <a:tc>
+                  <a:txBody>
+                    <a:bodyPr/>
+                    <a:lstStyle/>
+                    <a:p>
+                      <a:r>
+                        <a:rPr sz="900">
+                          <a:solidFill>
+                            <a:srgbClr val="1F2937"/>
+                          </a:solidFill>
+                        </a:rPr>
+                        <a:t>同步</a:t>
+                      </a:r>
+                    </a:p>
+                  </a:txBody>
+                  <a:tcPr marT="25400" marB="25400"/>
+                </a:tc>
+              </a:tr>
+              <a:tr h="152400">
+                <a:tc>
+                  <a:txBody>
+                    <a:bodyPr/>
+                    <a:lstStyle/>
+                    <a:p>
+                      <a:r>
+                        <a:rPr sz="900">
+                          <a:solidFill>
+                            <a:srgbClr val="1F2937"/>
+                          </a:solidFill>
+                        </a:rPr>
+                        <a:t>trigger_runbook</a:t>
+                      </a:r>
+                    </a:p>
+                  </a:txBody>
+                  <a:tcPr marT="25400" marB="25400">
                     <a:solidFill>
                       <a:srgbClr val="F7F8FA"/>
                     </a:solidFill>
@@ -9459,20 +10076,623 @@
                     <a:lstStyle/>
                     <a:p>
                       <a:r>
-                        <a:rPr sz="1000">
+                        <a:rPr sz="900">
                           <a:solidFill>
                             <a:srgbClr val="1F2937"/>
                           </a:solidFill>
                         </a:rPr>
-                        <a:t>-73%</a:t>
+                        <a:t>1-3s</a:t>
                       </a:r>
                     </a:p>
                   </a:txBody>
-                  <a:tcPr marT="50800" marB="50800" marL="101600" marR="101600">
+                  <a:tcPr marT="25400" marB="25400">
                     <a:solidFill>
                       <a:srgbClr val="F7F8FA"/>
                     </a:solidFill>
                   </a:tcPr>
+                </a:tc>
+                <a:tc>
+                  <a:txBody>
+                    <a:bodyPr/>
+                    <a:lstStyle/>
+                    <a:p>
+                      <a:r>
+                        <a:rPr sz="900">
+                          <a:solidFill>
+                            <a:srgbClr val="1F2937"/>
+                          </a:solidFill>
+                        </a:rPr>
+                        <a:t>同步</a:t>
+                      </a:r>
+                    </a:p>
+                  </a:txBody>
+                  <a:tcPr marT="25400" marB="25400">
+                    <a:solidFill>
+                      <a:srgbClr val="F7F8FA"/>
+                    </a:solidFill>
+                  </a:tcPr>
+                </a:tc>
+              </a:tr>
+              <a:tr h="152400">
+                <a:tc>
+                  <a:txBody>
+                    <a:bodyPr/>
+                    <a:lstStyle/>
+                    <a:p>
+                      <a:r>
+                        <a:rPr sz="900">
+                          <a:solidFill>
+                            <a:srgbClr val="1F2937"/>
+                          </a:solidFill>
+                        </a:rPr>
+                        <a:t>notify_im</a:t>
+                      </a:r>
+                    </a:p>
+                  </a:txBody>
+                  <a:tcPr marT="25400" marB="25400"/>
+                </a:tc>
+                <a:tc>
+                  <a:txBody>
+                    <a:bodyPr/>
+                    <a:lstStyle/>
+                    <a:p>
+                      <a:r>
+                        <a:rPr sz="900">
+                          <a:solidFill>
+                            <a:srgbClr val="1F2937"/>
+                          </a:solidFill>
+                        </a:rPr>
+                        <a:t>1-2s</a:t>
+                      </a:r>
+                    </a:p>
+                  </a:txBody>
+                  <a:tcPr marT="25400" marB="25400"/>
+                </a:tc>
+                <a:tc>
+                  <a:txBody>
+                    <a:bodyPr/>
+                    <a:lstStyle/>
+                    <a:p>
+                      <a:r>
+                        <a:rPr sz="900">
+                          <a:solidFill>
+                            <a:srgbClr val="1F2937"/>
+                          </a:solidFill>
+                        </a:rPr>
+                        <a:t>同步</a:t>
+                      </a:r>
+                    </a:p>
+                  </a:txBody>
+                  <a:tcPr marT="25400" marB="25400"/>
+                </a:tc>
+              </a:tr>
+            </a:tbl>
+          </a:graphicData>
+        </a:graphic>
+      </p:graphicFrame>
+      <p:sp>
+        <p:nvSpPr>
+          <p:cNvPr id="22" name="TextBox 21"/>
+          <p:cNvSpPr txBox="1"/>
+          <p:nvPr/>
+        </p:nvSpPr>
+        <p:spPr>
+          <a:xfrm>
+            <a:off x="6400800" y="5486400"/>
+            <a:ext cx="5303520" cy="365760"/>
+          </a:xfrm>
+          <a:prstGeom prst="rect">
+            <a:avLst/>
+          </a:prstGeom>
+          <a:noFill/>
+        </p:spPr>
+        <p:txBody>
+          <a:bodyPr wrap="square">
+            <a:spAutoFit/>
+          </a:bodyPr>
+          <a:lstStyle/>
+          <a:p>
+            <a:r>
+              <a:rPr sz="1200" b="1">
+                <a:solidFill>
+                  <a:srgbClr val="232F3E"/>
+                </a:solidFill>
+              </a:rPr>
+              <a:t>📊 系统扩展性</a:t>
+            </a:r>
+          </a:p>
+        </p:txBody>
+      </p:sp>
+      <p:graphicFrame>
+        <p:nvGraphicFramePr>
+          <p:cNvPr id="23" name="Table 22"/>
+          <p:cNvGraphicFramePr>
+            <a:graphicFrameLocks noGrp="1"/>
+          </p:cNvGraphicFramePr>
+          <p:nvPr/>
+        </p:nvGraphicFramePr>
+        <p:xfrm>
+          <a:off x="6400800" y="5852160"/>
+          <a:ext cx="5303520" cy="914400"/>
+        </p:xfrm>
+        <a:graphic>
+          <a:graphicData uri="http://schemas.openxmlformats.org/drawingml/2006/table">
+            <a:tbl>
+              <a:tblPr firstRow="1" bandRow="1">
+                <a:tableStyleId>{5C22544A-7EE6-4342-B048-85BDC9FD1C3A}</a:tableStyleId>
+              </a:tblPr>
+              <a:tblGrid>
+                <a:gridCol w="1325880"/>
+                <a:gridCol w="1325880"/>
+                <a:gridCol w="1325880"/>
+                <a:gridCol w="1325880"/>
+              </a:tblGrid>
+              <a:tr h="152400">
+                <a:tc>
+                  <a:txBody>
+                    <a:bodyPr/>
+                    <a:lstStyle/>
+                    <a:p>
+                      <a:r>
+                        <a:rPr sz="900" b="1">
+                          <a:solidFill>
+                            <a:srgbClr val="FFFFFF"/>
+                          </a:solidFill>
+                        </a:rPr>
+                        <a:t>维度</a:t>
+                      </a:r>
+                    </a:p>
+                  </a:txBody>
+                  <a:tcPr marT="25400" marB="25400">
+                    <a:solidFill>
+                      <a:srgbClr val="232F3E"/>
+                    </a:solidFill>
+                  </a:tcPr>
+                </a:tc>
+                <a:tc>
+                  <a:txBody>
+                    <a:bodyPr/>
+                    <a:lstStyle/>
+                    <a:p>
+                      <a:r>
+                        <a:rPr sz="900" b="1">
+                          <a:solidFill>
+                            <a:srgbClr val="FFFFFF"/>
+                          </a:solidFill>
+                        </a:rPr>
+                        <a:t>当前</a:t>
+                      </a:r>
+                    </a:p>
+                  </a:txBody>
+                  <a:tcPr marT="25400" marB="25400">
+                    <a:solidFill>
+                      <a:srgbClr val="232F3E"/>
+                    </a:solidFill>
+                  </a:tcPr>
+                </a:tc>
+                <a:tc>
+                  <a:txBody>
+                    <a:bodyPr/>
+                    <a:lstStyle/>
+                    <a:p>
+                      <a:r>
+                        <a:rPr sz="900" b="1">
+                          <a:solidFill>
+                            <a:srgbClr val="FFFFFF"/>
+                          </a:solidFill>
+                        </a:rPr>
+                        <a:t>上限</a:t>
+                      </a:r>
+                    </a:p>
+                  </a:txBody>
+                  <a:tcPr marT="25400" marB="25400">
+                    <a:solidFill>
+                      <a:srgbClr val="232F3E"/>
+                    </a:solidFill>
+                  </a:tcPr>
+                </a:tc>
+                <a:tc>
+                  <a:txBody>
+                    <a:bodyPr/>
+                    <a:lstStyle/>
+                    <a:p>
+                      <a:r>
+                        <a:rPr sz="900" b="1">
+                          <a:solidFill>
+                            <a:srgbClr val="FFFFFF"/>
+                          </a:solidFill>
+                        </a:rPr>
+                        <a:t>余量</a:t>
+                      </a:r>
+                    </a:p>
+                  </a:txBody>
+                  <a:tcPr marT="25400" marB="25400">
+                    <a:solidFill>
+                      <a:srgbClr val="232F3E"/>
+                    </a:solidFill>
+                  </a:tcPr>
+                </a:tc>
+              </a:tr>
+              <a:tr h="152400">
+                <a:tc>
+                  <a:txBody>
+                    <a:bodyPr/>
+                    <a:lstStyle/>
+                    <a:p>
+                      <a:r>
+                        <a:rPr sz="900">
+                          <a:solidFill>
+                            <a:srgbClr val="1F2937"/>
+                          </a:solidFill>
+                        </a:rPr>
+                        <a:t>Lambda 并发</a:t>
+                      </a:r>
+                    </a:p>
+                  </a:txBody>
+                  <a:tcPr marT="25400" marB="25400"/>
+                </a:tc>
+                <a:tc>
+                  <a:txBody>
+                    <a:bodyPr/>
+                    <a:lstStyle/>
+                    <a:p>
+                      <a:r>
+                        <a:rPr sz="900">
+                          <a:solidFill>
+                            <a:srgbClr val="1F2937"/>
+                          </a:solidFill>
+                        </a:rPr>
+                        <a:t>实测 1</a:t>
+                      </a:r>
+                    </a:p>
+                  </a:txBody>
+                  <a:tcPr marT="25400" marB="25400"/>
+                </a:tc>
+                <a:tc>
+                  <a:txBody>
+                    <a:bodyPr/>
+                    <a:lstStyle/>
+                    <a:p>
+                      <a:r>
+                        <a:rPr sz="900">
+                          <a:solidFill>
+                            <a:srgbClr val="1F2937"/>
+                          </a:solidFill>
+                        </a:rPr>
+                        <a:t>1000</a:t>
+                      </a:r>
+                    </a:p>
+                  </a:txBody>
+                  <a:tcPr marT="25400" marB="25400"/>
+                </a:tc>
+                <a:tc>
+                  <a:txBody>
+                    <a:bodyPr/>
+                    <a:lstStyle/>
+                    <a:p>
+                      <a:r>
+                        <a:rPr sz="900">
+                          <a:solidFill>
+                            <a:srgbClr val="1F2937"/>
+                          </a:solidFill>
+                        </a:rPr>
+                        <a:t>1000x</a:t>
+                      </a:r>
+                    </a:p>
+                  </a:txBody>
+                  <a:tcPr marT="25400" marB="25400"/>
+                </a:tc>
+              </a:tr>
+              <a:tr h="152400">
+                <a:tc>
+                  <a:txBody>
+                    <a:bodyPr/>
+                    <a:lstStyle/>
+                    <a:p>
+                      <a:r>
+                        <a:rPr sz="900">
+                          <a:solidFill>
+                            <a:srgbClr val="1F2937"/>
+                          </a:solidFill>
+                        </a:rPr>
+                        <a:t>API GW 限流</a:t>
+                      </a:r>
+                    </a:p>
+                  </a:txBody>
+                  <a:tcPr marT="25400" marB="25400">
+                    <a:solidFill>
+                      <a:srgbClr val="F7F8FA"/>
+                    </a:solidFill>
+                  </a:tcPr>
+                </a:tc>
+                <a:tc>
+                  <a:txBody>
+                    <a:bodyPr/>
+                    <a:lstStyle/>
+                    <a:p>
+                      <a:r>
+                        <a:rPr sz="900">
+                          <a:solidFill>
+                            <a:srgbClr val="1F2937"/>
+                          </a:solidFill>
+                        </a:rPr>
+                        <a:t>实测 &lt; 1 RPS</a:t>
+                      </a:r>
+                    </a:p>
+                  </a:txBody>
+                  <a:tcPr marT="25400" marB="25400">
+                    <a:solidFill>
+                      <a:srgbClr val="F7F8FA"/>
+                    </a:solidFill>
+                  </a:tcPr>
+                </a:tc>
+                <a:tc>
+                  <a:txBody>
+                    <a:bodyPr/>
+                    <a:lstStyle/>
+                    <a:p>
+                      <a:r>
+                        <a:rPr sz="900">
+                          <a:solidFill>
+                            <a:srgbClr val="1F2937"/>
+                          </a:solidFill>
+                        </a:rPr>
+                        <a:t>25 RPS</a:t>
+                      </a:r>
+                    </a:p>
+                  </a:txBody>
+                  <a:tcPr marT="25400" marB="25400">
+                    <a:solidFill>
+                      <a:srgbClr val="F7F8FA"/>
+                    </a:solidFill>
+                  </a:tcPr>
+                </a:tc>
+                <a:tc>
+                  <a:txBody>
+                    <a:bodyPr/>
+                    <a:lstStyle/>
+                    <a:p>
+                      <a:r>
+                        <a:rPr sz="900">
+                          <a:solidFill>
+                            <a:srgbClr val="1F2937"/>
+                          </a:solidFill>
+                        </a:rPr>
+                        <a:t>25x</a:t>
+                      </a:r>
+                    </a:p>
+                  </a:txBody>
+                  <a:tcPr marT="25400" marB="25400">
+                    <a:solidFill>
+                      <a:srgbClr val="F7F8FA"/>
+                    </a:solidFill>
+                  </a:tcPr>
+                </a:tc>
+              </a:tr>
+              <a:tr h="152400">
+                <a:tc>
+                  <a:txBody>
+                    <a:bodyPr/>
+                    <a:lstStyle/>
+                    <a:p>
+                      <a:r>
+                        <a:rPr sz="900">
+                          <a:solidFill>
+                            <a:srgbClr val="1F2937"/>
+                          </a:solidFill>
+                        </a:rPr>
+                        <a:t>DOA 并发调查</a:t>
+                      </a:r>
+                    </a:p>
+                  </a:txBody>
+                  <a:tcPr marT="25400" marB="25400"/>
+                </a:tc>
+                <a:tc>
+                  <a:txBody>
+                    <a:bodyPr/>
+                    <a:lstStyle/>
+                    <a:p>
+                      <a:r>
+                        <a:rPr sz="900">
+                          <a:solidFill>
+                            <a:srgbClr val="1F2937"/>
+                          </a:solidFill>
+                        </a:rPr>
+                        <a:t>1-5</a:t>
+                      </a:r>
+                    </a:p>
+                  </a:txBody>
+                  <a:tcPr marT="25400" marB="25400"/>
+                </a:tc>
+                <a:tc>
+                  <a:txBody>
+                    <a:bodyPr/>
+                    <a:lstStyle/>
+                    <a:p>
+                      <a:r>
+                        <a:rPr sz="900">
+                          <a:solidFill>
+                            <a:srgbClr val="1F2937"/>
+                          </a:solidFill>
+                        </a:rPr>
+                        <a:t>100</a:t>
+                      </a:r>
+                    </a:p>
+                  </a:txBody>
+                  <a:tcPr marT="25400" marB="25400"/>
+                </a:tc>
+                <a:tc>
+                  <a:txBody>
+                    <a:bodyPr/>
+                    <a:lstStyle/>
+                    <a:p>
+                      <a:r>
+                        <a:rPr sz="900">
+                          <a:solidFill>
+                            <a:srgbClr val="1F2937"/>
+                          </a:solidFill>
+                        </a:rPr>
+                        <a:t>20x</a:t>
+                      </a:r>
+                    </a:p>
+                  </a:txBody>
+                  <a:tcPr marT="25400" marB="25400"/>
+                </a:tc>
+              </a:tr>
+              <a:tr h="152400">
+                <a:tc>
+                  <a:txBody>
+                    <a:bodyPr/>
+                    <a:lstStyle/>
+                    <a:p>
+                      <a:r>
+                        <a:rPr sz="900">
+                          <a:solidFill>
+                            <a:srgbClr val="1F2937"/>
+                          </a:solidFill>
+                        </a:rPr>
+                        <a:t>DDB 容量</a:t>
+                      </a:r>
+                    </a:p>
+                  </a:txBody>
+                  <a:tcPr marT="25400" marB="25400">
+                    <a:solidFill>
+                      <a:srgbClr val="F7F8FA"/>
+                    </a:solidFill>
+                  </a:tcPr>
+                </a:tc>
+                <a:tc>
+                  <a:txBody>
+                    <a:bodyPr/>
+                    <a:lstStyle/>
+                    <a:p>
+                      <a:r>
+                        <a:rPr sz="900">
+                          <a:solidFill>
+                            <a:srgbClr val="1F2937"/>
+                          </a:solidFill>
+                        </a:rPr>
+                        <a:t>&lt;1MB</a:t>
+                      </a:r>
+                    </a:p>
+                  </a:txBody>
+                  <a:tcPr marT="25400" marB="25400">
+                    <a:solidFill>
+                      <a:srgbClr val="F7F8FA"/>
+                    </a:solidFill>
+                  </a:tcPr>
+                </a:tc>
+                <a:tc>
+                  <a:txBody>
+                    <a:bodyPr/>
+                    <a:lstStyle/>
+                    <a:p>
+                      <a:r>
+                        <a:rPr sz="900">
+                          <a:solidFill>
+                            <a:srgbClr val="1F2937"/>
+                          </a:solidFill>
+                        </a:rPr>
+                        <a:t>PAY_PER_REQ</a:t>
+                      </a:r>
+                    </a:p>
+                  </a:txBody>
+                  <a:tcPr marT="25400" marB="25400">
+                    <a:solidFill>
+                      <a:srgbClr val="F7F8FA"/>
+                    </a:solidFill>
+                  </a:tcPr>
+                </a:tc>
+                <a:tc>
+                  <a:txBody>
+                    <a:bodyPr/>
+                    <a:lstStyle/>
+                    <a:p>
+                      <a:r>
+                        <a:rPr sz="900">
+                          <a:solidFill>
+                            <a:srgbClr val="1F2937"/>
+                          </a:solidFill>
+                        </a:rPr>
+                        <a:t>无限</a:t>
+                      </a:r>
+                    </a:p>
+                  </a:txBody>
+                  <a:tcPr marT="25400" marB="25400">
+                    <a:solidFill>
+                      <a:srgbClr val="F7F8FA"/>
+                    </a:solidFill>
+                  </a:tcPr>
+                </a:tc>
+              </a:tr>
+              <a:tr h="152400">
+                <a:tc>
+                  <a:txBody>
+                    <a:bodyPr/>
+                    <a:lstStyle/>
+                    <a:p>
+                      <a:r>
+                        <a:rPr sz="900">
+                          <a:solidFill>
+                            <a:srgbClr val="1F2937"/>
+                          </a:solidFill>
+                        </a:rPr>
+                        <a:t>调用量/月</a:t>
+                      </a:r>
+                    </a:p>
+                  </a:txBody>
+                  <a:tcPr marT="25400" marB="25400"/>
+                </a:tc>
+                <a:tc>
+                  <a:txBody>
+                    <a:bodyPr/>
+                    <a:lstStyle/>
+                    <a:p>
+                      <a:r>
+                        <a:rPr sz="900">
+                          <a:solidFill>
+                            <a:srgbClr val="1F2937"/>
+                          </a:solidFill>
+                        </a:rPr>
+                        <a:t>~1000</a:t>
+                      </a:r>
+                    </a:p>
+                  </a:txBody>
+                  <a:tcPr marT="25400" marB="25400"/>
+                </a:tc>
+                <a:tc>
+                  <a:txBody>
+                    <a:bodyPr/>
+                    <a:lstStyle/>
+                    <a:p>
+                      <a:r>
+                        <a:rPr sz="900">
+                          <a:solidFill>
+                            <a:srgbClr val="1F2937"/>
+                          </a:solidFill>
+                        </a:rPr>
+                        <a:t>~25,000</a:t>
+                      </a:r>
+                    </a:p>
+                  </a:txBody>
+                  <a:tcPr marT="25400" marB="25400"/>
+                </a:tc>
+                <a:tc>
+                  <a:txBody>
+                    <a:bodyPr/>
+                    <a:lstStyle/>
+                    <a:p>
+                      <a:r>
+                        <a:rPr sz="900">
+                          <a:solidFill>
+                            <a:srgbClr val="1F2937"/>
+                          </a:solidFill>
+                        </a:rPr>
+                        <a:t>25x</a:t>
+                      </a:r>
+                    </a:p>
+                  </a:txBody>
+                  <a:tcPr marT="25400" marB="25400"/>
                 </a:tc>
               </a:tr>
             </a:tbl>

</xml_diff>